<commit_message>
Slides: add live-demo commands + equations appendix (16 slides)
- Slide 15 "Live Demo — Run Commands": copy-paste sink/source QPSK-sc ARQ
  commands in styled code boxes, plus how to swap scheme / go OFDM / tune 8-PSK.
- Slide 16 "Appendix — Key Equations": matplotlib-mathtext render of the core
  equations (signal model, min-distance/OFDM, ACQ + Gardner, CFO + OFDM CPE +
  PLL, LS equalizer, Viterbi) — rendered to assets/equations.png.

Co-Authored-By: Claude Opus 4.8 (1M context) <noreply@anthropic.com>
</commit_message>
<xml_diff>
--- a/slides/SDR_System_Overview.pptx
+++ b/slides/SDR_System_Overview.pptx
@@ -19,6 +19,8 @@
     <p:sldId id="267" r:id="rId18"/>
     <p:sldId id="268" r:id="rId19"/>
     <p:sldId id="269" r:id="rId20"/>
+    <p:sldId id="270" r:id="rId21"/>
+    <p:sldId id="271" r:id="rId22"/>
   </p:sldIdLst>
   <p:sldSz cx="12191695" cy="6858000" type="screen4x3"/>
   <p:notesSz cx="6858000" cy="9144000"/>
@@ -5525,6 +5527,691 @@
           </a:p>
         </p:txBody>
       </p:sp>
+    </p:spTree>
+  </p:cSld>
+  <p:clrMapOvr>
+    <a:masterClrMapping/>
+  </p:clrMapOvr>
+</p:sld>
+</file>
+
+<file path=ppt/slides/slide15.xml><?xml version="1.0" encoding="utf-8"?>
+<p:sld xmlns:a="http://schemas.openxmlformats.org/drawingml/2006/main" xmlns:p="http://schemas.openxmlformats.org/presentationml/2006/main" xmlns:r="http://schemas.openxmlformats.org/officeDocument/2006/relationships">
+  <p:cSld>
+    <p:spTree>
+      <p:nvGrpSpPr>
+        <p:cNvPr id="1" name=""/>
+        <p:cNvGrpSpPr/>
+        <p:nvPr/>
+      </p:nvGrpSpPr>
+      <p:grpSpPr/>
+      <p:sp>
+        <p:nvSpPr>
+          <p:cNvPr id="2" name="Rectangle 1"/>
+          <p:cNvSpPr/>
+          <p:nvPr/>
+        </p:nvSpPr>
+        <p:spPr>
+          <a:xfrm>
+            <a:off x="0" y="0"/>
+            <a:ext cx="12191695" cy="1051560"/>
+          </a:xfrm>
+          <a:prstGeom prst="rect">
+            <a:avLst/>
+          </a:prstGeom>
+          <a:solidFill>
+            <a:srgbClr val="0F2E4E"/>
+          </a:solidFill>
+          <a:ln>
+            <a:noFill/>
+          </a:ln>
+          <a:effectLst/>
+        </p:spPr>
+        <p:style>
+          <a:lnRef idx="1">
+            <a:schemeClr val="accent1"/>
+          </a:lnRef>
+          <a:fillRef idx="3">
+            <a:schemeClr val="accent1"/>
+          </a:fillRef>
+          <a:effectRef idx="2">
+            <a:schemeClr val="accent1"/>
+          </a:effectRef>
+          <a:fontRef idx="minor">
+            <a:schemeClr val="lt1"/>
+          </a:fontRef>
+        </p:style>
+        <p:txBody>
+          <a:bodyPr rtlCol="0" anchor="ctr"/>
+          <a:lstStyle/>
+          <a:p>
+            <a:pPr algn="ctr"/>
+          </a:p>
+        </p:txBody>
+      </p:sp>
+      <p:sp>
+        <p:nvSpPr>
+          <p:cNvPr id="3" name="Rectangle 2"/>
+          <p:cNvSpPr/>
+          <p:nvPr/>
+        </p:nvSpPr>
+        <p:spPr>
+          <a:xfrm>
+            <a:off x="0" y="1051560"/>
+            <a:ext cx="12191695" cy="73152"/>
+          </a:xfrm>
+          <a:prstGeom prst="rect">
+            <a:avLst/>
+          </a:prstGeom>
+          <a:solidFill>
+            <a:srgbClr val="E87A1E"/>
+          </a:solidFill>
+          <a:ln>
+            <a:noFill/>
+          </a:ln>
+          <a:effectLst/>
+        </p:spPr>
+        <p:style>
+          <a:lnRef idx="1">
+            <a:schemeClr val="accent1"/>
+          </a:lnRef>
+          <a:fillRef idx="3">
+            <a:schemeClr val="accent1"/>
+          </a:fillRef>
+          <a:effectRef idx="2">
+            <a:schemeClr val="accent1"/>
+          </a:effectRef>
+          <a:fontRef idx="minor">
+            <a:schemeClr val="lt1"/>
+          </a:fontRef>
+        </p:style>
+        <p:txBody>
+          <a:bodyPr rtlCol="0" anchor="ctr"/>
+          <a:lstStyle/>
+          <a:p>
+            <a:pPr algn="ctr"/>
+          </a:p>
+        </p:txBody>
+      </p:sp>
+      <p:sp>
+        <p:nvSpPr>
+          <p:cNvPr id="4" name="TextBox 3"/>
+          <p:cNvSpPr txBox="1"/>
+          <p:nvPr/>
+        </p:nvSpPr>
+        <p:spPr>
+          <a:xfrm>
+            <a:off x="502920" y="146304"/>
+            <a:ext cx="10515600" cy="777240"/>
+          </a:xfrm>
+          <a:prstGeom prst="rect">
+            <a:avLst/>
+          </a:prstGeom>
+          <a:noFill/>
+        </p:spPr>
+        <p:txBody>
+          <a:bodyPr wrap="square">
+            <a:spAutoFit/>
+          </a:bodyPr>
+          <a:lstStyle/>
+          <a:p>
+            <a:pPr algn="l"/>
+            <a:r>
+              <a:rPr sz="3000" b="1">
+                <a:solidFill>
+                  <a:srgbClr val="FFFFFF"/>
+                </a:solidFill>
+                <a:latin typeface="Calibri Light"/>
+              </a:rPr>
+              <a:t>Live Demo — Run Commands</a:t>
+            </a:r>
+          </a:p>
+        </p:txBody>
+      </p:sp>
+      <p:sp>
+        <p:nvSpPr>
+          <p:cNvPr id="5" name="TextBox 4"/>
+          <p:cNvSpPr txBox="1"/>
+          <p:nvPr/>
+        </p:nvSpPr>
+        <p:spPr>
+          <a:xfrm>
+            <a:off x="11247120" y="310896"/>
+            <a:ext cx="822960" cy="548640"/>
+          </a:xfrm>
+          <a:prstGeom prst="rect">
+            <a:avLst/>
+          </a:prstGeom>
+          <a:noFill/>
+        </p:spPr>
+        <p:txBody>
+          <a:bodyPr wrap="square">
+            <a:spAutoFit/>
+          </a:bodyPr>
+          <a:lstStyle/>
+          <a:p>
+            <a:pPr algn="r"/>
+            <a:r>
+              <a:rPr sz="1600" b="1">
+                <a:solidFill>
+                  <a:srgbClr val="9FB6CC"/>
+                </a:solidFill>
+                <a:latin typeface="Calibri"/>
+              </a:rPr>
+              <a:t>15</a:t>
+            </a:r>
+          </a:p>
+        </p:txBody>
+      </p:sp>
+      <p:sp>
+        <p:nvSpPr>
+          <p:cNvPr id="6" name="TextBox 5"/>
+          <p:cNvSpPr txBox="1"/>
+          <p:nvPr/>
+        </p:nvSpPr>
+        <p:spPr>
+          <a:xfrm>
+            <a:off x="548640" y="1234440"/>
+            <a:ext cx="11155680" cy="457200"/>
+          </a:xfrm>
+          <a:prstGeom prst="rect">
+            <a:avLst/>
+          </a:prstGeom>
+          <a:noFill/>
+        </p:spPr>
+        <p:txBody>
+          <a:bodyPr wrap="square">
+            <a:spAutoFit/>
+          </a:bodyPr>
+          <a:lstStyle/>
+          <a:p>
+            <a:pPr algn="l"/>
+            <a:r>
+              <a:rPr sz="1600" b="1">
+                <a:solidFill>
+                  <a:srgbClr val="0F2E4E"/>
+                </a:solidFill>
+                <a:latin typeface="Calibri"/>
+              </a:rPr>
+              <a:t>QPSK single-carrier + FEC + stop-and-wait ARQ.  Start the SINK (RX) first, then the SOURCE (TX).</a:t>
+            </a:r>
+          </a:p>
+        </p:txBody>
+      </p:sp>
+      <p:sp>
+        <p:nvSpPr>
+          <p:cNvPr id="7" name="Rounded Rectangle 6"/>
+          <p:cNvSpPr/>
+          <p:nvPr/>
+        </p:nvSpPr>
+        <p:spPr>
+          <a:xfrm>
+            <a:off x="548640" y="1783080"/>
+            <a:ext cx="11109960" cy="1417320"/>
+          </a:xfrm>
+          <a:prstGeom prst="roundRect">
+            <a:avLst/>
+          </a:prstGeom>
+          <a:solidFill>
+            <a:srgbClr val="1B2533"/>
+          </a:solidFill>
+          <a:ln w="9525">
+            <a:solidFill>
+              <a:srgbClr val="3A4A5E"/>
+            </a:solidFill>
+          </a:ln>
+          <a:effectLst/>
+        </p:spPr>
+        <p:style>
+          <a:lnRef idx="1">
+            <a:schemeClr val="accent1"/>
+          </a:lnRef>
+          <a:fillRef idx="3">
+            <a:schemeClr val="accent1"/>
+          </a:fillRef>
+          <a:effectRef idx="2">
+            <a:schemeClr val="accent1"/>
+          </a:effectRef>
+          <a:fontRef idx="minor">
+            <a:schemeClr val="lt1"/>
+          </a:fontRef>
+        </p:style>
+        <p:txBody>
+          <a:bodyPr rtlCol="0" anchor="ctr" wrap="square" lIns="137160" tIns="73152"/>
+          <a:lstStyle/>
+          <a:p>
+            <a:pPr algn="ctr"/>
+            <a:r>
+              <a:rPr sz="1100">
+                <a:solidFill>
+                  <a:srgbClr val="86C591"/>
+                </a:solidFill>
+                <a:latin typeface="Consolas"/>
+              </a:rPr>
+              <a:t># TERMINAL 1 — Sink / RX   (auto-stops when all chunks verified; saves the figure)</a:t>
+            </a:r>
+          </a:p>
+          <a:p>
+            <a:r>
+              <a:rPr sz="1100">
+                <a:solidFill>
+                  <a:srgbClr val="D6E6F2"/>
+                </a:solidFill>
+                <a:latin typeface="Consolas"/>
+              </a:rPr>
+              <a:t>./sdr_system --role sink_arq --rx-args serial=30CD3F7 --tx-args serial=30CD3F7 \</a:t>
+            </a:r>
+          </a:p>
+          <a:p>
+            <a:r>
+              <a:rPr sz="1100">
+                <a:solidFill>
+                  <a:srgbClr val="D6E6F2"/>
+                </a:solidFill>
+                <a:latin typeface="Consolas"/>
+              </a:rPr>
+              <a:t>  --rx-subdev A:A --rx-ant RX2 --rx-freq 915e6 --rx-rate 1.6e6 --rx-gain 20 \</a:t>
+            </a:r>
+          </a:p>
+          <a:p>
+            <a:r>
+              <a:rPr sz="1100">
+                <a:solidFill>
+                  <a:srgbClr val="D6E6F2"/>
+                </a:solidFill>
+                <a:latin typeface="Consolas"/>
+              </a:rPr>
+              <a:t>  --scheme QPSK --fec true --ack-transport tcp --ack-port 5599 --det-mult 3</a:t>
+            </a:r>
+          </a:p>
+        </p:txBody>
+      </p:sp>
+      <p:sp>
+        <p:nvSpPr>
+          <p:cNvPr id="8" name="Rounded Rectangle 7"/>
+          <p:cNvSpPr/>
+          <p:nvPr/>
+        </p:nvSpPr>
+        <p:spPr>
+          <a:xfrm>
+            <a:off x="548640" y="3337560"/>
+            <a:ext cx="11109960" cy="1554480"/>
+          </a:xfrm>
+          <a:prstGeom prst="roundRect">
+            <a:avLst/>
+          </a:prstGeom>
+          <a:solidFill>
+            <a:srgbClr val="1B2533"/>
+          </a:solidFill>
+          <a:ln w="9525">
+            <a:solidFill>
+              <a:srgbClr val="3A4A5E"/>
+            </a:solidFill>
+          </a:ln>
+          <a:effectLst/>
+        </p:spPr>
+        <p:style>
+          <a:lnRef idx="1">
+            <a:schemeClr val="accent1"/>
+          </a:lnRef>
+          <a:fillRef idx="3">
+            <a:schemeClr val="accent1"/>
+          </a:fillRef>
+          <a:effectRef idx="2">
+            <a:schemeClr val="accent1"/>
+          </a:effectRef>
+          <a:fontRef idx="minor">
+            <a:schemeClr val="lt1"/>
+          </a:fontRef>
+        </p:style>
+        <p:txBody>
+          <a:bodyPr rtlCol="0" anchor="ctr" wrap="square" lIns="137160" tIns="73152"/>
+          <a:lstStyle/>
+          <a:p>
+            <a:pPr algn="ctr"/>
+            <a:r>
+              <a:rPr sz="1100">
+                <a:solidFill>
+                  <a:srgbClr val="86C591"/>
+                </a:solidFill>
+                <a:latin typeface="Consolas"/>
+              </a:rPr>
+              <a:t># TERMINAL 2 — Source / TX   (retransmits until every chunk is ACKed)</a:t>
+            </a:r>
+          </a:p>
+          <a:p>
+            <a:r>
+              <a:rPr sz="1100">
+                <a:solidFill>
+                  <a:srgbClr val="D6E6F2"/>
+                </a:solidFill>
+                <a:latin typeface="Consolas"/>
+              </a:rPr>
+              <a:t>./sdr_system --role source_arq --tx-args serial=30CD424 --rx-args serial=30CD424 \</a:t>
+            </a:r>
+          </a:p>
+          <a:p>
+            <a:r>
+              <a:rPr sz="1100">
+                <a:solidFill>
+                  <a:srgbClr val="D6E6F2"/>
+                </a:solidFill>
+                <a:latin typeface="Consolas"/>
+              </a:rPr>
+              <a:t>  --tx-subdev A:A --tx-ant TX/RX --tx-freq 915e6 --tx-rate 1.6e6 --tx-gain 78 \</a:t>
+            </a:r>
+          </a:p>
+          <a:p>
+            <a:r>
+              <a:rPr sz="1100">
+                <a:solidFill>
+                  <a:srgbClr val="D6E6F2"/>
+                </a:solidFill>
+                <a:latin typeface="Consolas"/>
+              </a:rPr>
+              <a:t>  --scheme QPSK --fec true --ack-transport tcp --ack-host 127.0.0.1 \</a:t>
+            </a:r>
+          </a:p>
+          <a:p>
+            <a:r>
+              <a:rPr sz="1100">
+                <a:solidFill>
+                  <a:srgbClr val="D6E6F2"/>
+                </a:solidFill>
+                <a:latin typeface="Consolas"/>
+              </a:rPr>
+              <a:t>  --ack-port 5599 --timeout 3000</a:t>
+            </a:r>
+          </a:p>
+        </p:txBody>
+      </p:sp>
+      <p:sp>
+        <p:nvSpPr>
+          <p:cNvPr id="9" name="TextBox 8"/>
+          <p:cNvSpPr txBox="1"/>
+          <p:nvPr/>
+        </p:nvSpPr>
+        <p:spPr>
+          <a:xfrm>
+            <a:off x="640080" y="5029200"/>
+            <a:ext cx="10972800" cy="1463040"/>
+          </a:xfrm>
+          <a:prstGeom prst="rect">
+            <a:avLst/>
+          </a:prstGeom>
+          <a:noFill/>
+        </p:spPr>
+        <p:txBody>
+          <a:bodyPr wrap="square">
+            <a:spAutoFit/>
+          </a:bodyPr>
+          <a:lstStyle/>
+          <a:p>
+            <a:pPr algn="l">
+              <a:spcAft>
+                <a:spcPts val="500"/>
+              </a:spcAft>
+            </a:pPr>
+            <a:r>
+              <a:rPr sz="1400" b="0">
+                <a:solidFill>
+                  <a:srgbClr val="1F6FB2"/>
+                </a:solidFill>
+                <a:latin typeface="Calibri"/>
+              </a:rPr>
+              <a:t>●  Other schemes: swap --scheme  (BPSK · 8-PSK · DBPSK · DQPSK)</a:t>
+            </a:r>
+          </a:p>
+          <a:p>
+            <a:pPr algn="l">
+              <a:spcAft>
+                <a:spcPts val="500"/>
+              </a:spcAft>
+            </a:pPr>
+            <a:r>
+              <a:rPr sz="1400" b="0">
+                <a:solidFill>
+                  <a:srgbClr val="1F6FB2"/>
+                </a:solidFill>
+                <a:latin typeface="Calibri"/>
+              </a:rPr>
+              <a:t>●  OFDM: add  --waveform ofdm --ofdm-fft 64 --ofdm-cp 16 --ofdm-tx-peak 0.5</a:t>
+            </a:r>
+          </a:p>
+          <a:p>
+            <a:pPr algn="l">
+              <a:spcAft>
+                <a:spcPts val="500"/>
+              </a:spcAft>
+            </a:pPr>
+            <a:r>
+              <a:rPr sz="1400" b="0">
+                <a:solidFill>
+                  <a:srgbClr val="1F6FB2"/>
+                </a:solidFill>
+                <a:latin typeface="Calibri"/>
+              </a:rPr>
+              <a:t>●  8-PSK needs more TX power: --rx-gain 16 --tx-gain 86</a:t>
+            </a:r>
+          </a:p>
+          <a:p>
+            <a:pPr algn="l">
+              <a:spcAft>
+                <a:spcPts val="500"/>
+              </a:spcAft>
+            </a:pPr>
+            <a:r>
+              <a:rPr sz="1400" b="0">
+                <a:solidFill>
+                  <a:srgbClr val="1F6FB2"/>
+                </a:solidFill>
+                <a:latin typeface="Calibri"/>
+              </a:rPr>
+              <a:t>●  Live output: per-chunk CRC-OK, then the auto-saved constellation figure</a:t>
+            </a:r>
+          </a:p>
+        </p:txBody>
+      </p:sp>
+    </p:spTree>
+  </p:cSld>
+  <p:clrMapOvr>
+    <a:masterClrMapping/>
+  </p:clrMapOvr>
+</p:sld>
+</file>
+
+<file path=ppt/slides/slide16.xml><?xml version="1.0" encoding="utf-8"?>
+<p:sld xmlns:a="http://schemas.openxmlformats.org/drawingml/2006/main" xmlns:p="http://schemas.openxmlformats.org/presentationml/2006/main" xmlns:r="http://schemas.openxmlformats.org/officeDocument/2006/relationships">
+  <p:cSld>
+    <p:spTree>
+      <p:nvGrpSpPr>
+        <p:cNvPr id="1" name=""/>
+        <p:cNvGrpSpPr/>
+        <p:nvPr/>
+      </p:nvGrpSpPr>
+      <p:grpSpPr/>
+      <p:sp>
+        <p:nvSpPr>
+          <p:cNvPr id="2" name="Rectangle 1"/>
+          <p:cNvSpPr/>
+          <p:nvPr/>
+        </p:nvSpPr>
+        <p:spPr>
+          <a:xfrm>
+            <a:off x="0" y="0"/>
+            <a:ext cx="12191695" cy="1051560"/>
+          </a:xfrm>
+          <a:prstGeom prst="rect">
+            <a:avLst/>
+          </a:prstGeom>
+          <a:solidFill>
+            <a:srgbClr val="0F2E4E"/>
+          </a:solidFill>
+          <a:ln>
+            <a:noFill/>
+          </a:ln>
+          <a:effectLst/>
+        </p:spPr>
+        <p:style>
+          <a:lnRef idx="1">
+            <a:schemeClr val="accent1"/>
+          </a:lnRef>
+          <a:fillRef idx="3">
+            <a:schemeClr val="accent1"/>
+          </a:fillRef>
+          <a:effectRef idx="2">
+            <a:schemeClr val="accent1"/>
+          </a:effectRef>
+          <a:fontRef idx="minor">
+            <a:schemeClr val="lt1"/>
+          </a:fontRef>
+        </p:style>
+        <p:txBody>
+          <a:bodyPr rtlCol="0" anchor="ctr"/>
+          <a:lstStyle/>
+          <a:p>
+            <a:pPr algn="ctr"/>
+          </a:p>
+        </p:txBody>
+      </p:sp>
+      <p:sp>
+        <p:nvSpPr>
+          <p:cNvPr id="3" name="Rectangle 2"/>
+          <p:cNvSpPr/>
+          <p:nvPr/>
+        </p:nvSpPr>
+        <p:spPr>
+          <a:xfrm>
+            <a:off x="0" y="1051560"/>
+            <a:ext cx="12191695" cy="73152"/>
+          </a:xfrm>
+          <a:prstGeom prst="rect">
+            <a:avLst/>
+          </a:prstGeom>
+          <a:solidFill>
+            <a:srgbClr val="E87A1E"/>
+          </a:solidFill>
+          <a:ln>
+            <a:noFill/>
+          </a:ln>
+          <a:effectLst/>
+        </p:spPr>
+        <p:style>
+          <a:lnRef idx="1">
+            <a:schemeClr val="accent1"/>
+          </a:lnRef>
+          <a:fillRef idx="3">
+            <a:schemeClr val="accent1"/>
+          </a:fillRef>
+          <a:effectRef idx="2">
+            <a:schemeClr val="accent1"/>
+          </a:effectRef>
+          <a:fontRef idx="minor">
+            <a:schemeClr val="lt1"/>
+          </a:fontRef>
+        </p:style>
+        <p:txBody>
+          <a:bodyPr rtlCol="0" anchor="ctr"/>
+          <a:lstStyle/>
+          <a:p>
+            <a:pPr algn="ctr"/>
+          </a:p>
+        </p:txBody>
+      </p:sp>
+      <p:sp>
+        <p:nvSpPr>
+          <p:cNvPr id="4" name="TextBox 3"/>
+          <p:cNvSpPr txBox="1"/>
+          <p:nvPr/>
+        </p:nvSpPr>
+        <p:spPr>
+          <a:xfrm>
+            <a:off x="502920" y="146304"/>
+            <a:ext cx="10515600" cy="777240"/>
+          </a:xfrm>
+          <a:prstGeom prst="rect">
+            <a:avLst/>
+          </a:prstGeom>
+          <a:noFill/>
+        </p:spPr>
+        <p:txBody>
+          <a:bodyPr wrap="square">
+            <a:spAutoFit/>
+          </a:bodyPr>
+          <a:lstStyle/>
+          <a:p>
+            <a:pPr algn="l"/>
+            <a:r>
+              <a:rPr sz="3000" b="1">
+                <a:solidFill>
+                  <a:srgbClr val="FFFFFF"/>
+                </a:solidFill>
+                <a:latin typeface="Calibri Light"/>
+              </a:rPr>
+              <a:t>Appendix — Key Equations</a:t>
+            </a:r>
+          </a:p>
+        </p:txBody>
+      </p:sp>
+      <p:sp>
+        <p:nvSpPr>
+          <p:cNvPr id="5" name="TextBox 4"/>
+          <p:cNvSpPr txBox="1"/>
+          <p:nvPr/>
+        </p:nvSpPr>
+        <p:spPr>
+          <a:xfrm>
+            <a:off x="11247120" y="310896"/>
+            <a:ext cx="822960" cy="548640"/>
+          </a:xfrm>
+          <a:prstGeom prst="rect">
+            <a:avLst/>
+          </a:prstGeom>
+          <a:noFill/>
+        </p:spPr>
+        <p:txBody>
+          <a:bodyPr wrap="square">
+            <a:spAutoFit/>
+          </a:bodyPr>
+          <a:lstStyle/>
+          <a:p>
+            <a:pPr algn="r"/>
+            <a:r>
+              <a:rPr sz="1600" b="1">
+                <a:solidFill>
+                  <a:srgbClr val="9FB6CC"/>
+                </a:solidFill>
+                <a:latin typeface="Calibri"/>
+              </a:rPr>
+              <a:t>16</a:t>
+            </a:r>
+          </a:p>
+        </p:txBody>
+      </p:sp>
+      <p:pic>
+        <p:nvPicPr>
+          <p:cNvPr id="6" name="Picture 5" descr="equations.png"/>
+          <p:cNvPicPr>
+            <a:picLocks noChangeAspect="1"/>
+          </p:cNvPicPr>
+          <p:nvPr/>
+        </p:nvPicPr>
+        <p:blipFill>
+          <a:blip r:embed="rId2"/>
+          <a:stretch>
+            <a:fillRect/>
+          </a:stretch>
+        </p:blipFill>
+        <p:spPr>
+          <a:xfrm>
+            <a:off x="1371600" y="1371600"/>
+            <a:ext cx="9564579" cy="5303520"/>
+          </a:xfrm>
+          <a:prstGeom prst="rect">
+            <a:avLst/>
+          </a:prstGeom>
+        </p:spPr>
+      </p:pic>
     </p:spTree>
   </p:cSld>
   <p:clrMapOvr>

</xml_diff>